<commit_message>
[T06] fix(docs): actualizar enlaces del repositorio y tablero Kanban en documentos de Seguimiento 1 y README
</commit_message>
<xml_diff>
--- a/06_Evidencias/Sustentación Seguimiento 1 TutorU.pptx
+++ b/06_Evidencias/Sustentación Seguimiento 1 TutorU.pptx
@@ -315,7 +315,7 @@
           <a:p>
             <a:fld id="{5BCAD085-E8A6-8845-BD4E-CB4CCA059FC4}" type="datetimeFigureOut">
               <a:rPr lang="en-US" smtClean="0"/>
-              <a:t>09/03/2026</a:t>
+              <a:t>09/04/2026</a:t>
             </a:fld>
             <a:endParaRPr lang="en-US"/>
           </a:p>
@@ -483,7 +483,7 @@
           <a:p>
             <a:fld id="{5BCAD085-E8A6-8845-BD4E-CB4CCA059FC4}" type="datetimeFigureOut">
               <a:rPr lang="en-US" smtClean="0"/>
-              <a:t>09/03/2026</a:t>
+              <a:t>09/04/2026</a:t>
             </a:fld>
             <a:endParaRPr lang="en-US"/>
           </a:p>
@@ -661,7 +661,7 @@
           <a:p>
             <a:fld id="{5BCAD085-E8A6-8845-BD4E-CB4CCA059FC4}" type="datetimeFigureOut">
               <a:rPr lang="en-US" smtClean="0"/>
-              <a:t>09/03/2026</a:t>
+              <a:t>09/04/2026</a:t>
             </a:fld>
             <a:endParaRPr lang="en-US"/>
           </a:p>
@@ -829,7 +829,7 @@
           <a:p>
             <a:fld id="{5BCAD085-E8A6-8845-BD4E-CB4CCA059FC4}" type="datetimeFigureOut">
               <a:rPr lang="en-US" smtClean="0"/>
-              <a:t>09/03/2026</a:t>
+              <a:t>09/04/2026</a:t>
             </a:fld>
             <a:endParaRPr lang="en-US"/>
           </a:p>
@@ -1074,7 +1074,7 @@
           <a:p>
             <a:fld id="{5BCAD085-E8A6-8845-BD4E-CB4CCA059FC4}" type="datetimeFigureOut">
               <a:rPr lang="en-US" smtClean="0"/>
-              <a:t>09/03/2026</a:t>
+              <a:t>09/04/2026</a:t>
             </a:fld>
             <a:endParaRPr lang="en-US"/>
           </a:p>
@@ -1359,7 +1359,7 @@
           <a:p>
             <a:fld id="{5BCAD085-E8A6-8845-BD4E-CB4CCA059FC4}" type="datetimeFigureOut">
               <a:rPr lang="en-US" smtClean="0"/>
-              <a:t>09/03/2026</a:t>
+              <a:t>09/04/2026</a:t>
             </a:fld>
             <a:endParaRPr lang="en-US"/>
           </a:p>
@@ -1778,7 +1778,7 @@
           <a:p>
             <a:fld id="{5BCAD085-E8A6-8845-BD4E-CB4CCA059FC4}" type="datetimeFigureOut">
               <a:rPr lang="en-US" smtClean="0"/>
-              <a:t>09/03/2026</a:t>
+              <a:t>09/04/2026</a:t>
             </a:fld>
             <a:endParaRPr lang="en-US"/>
           </a:p>
@@ -1895,7 +1895,7 @@
           <a:p>
             <a:fld id="{5BCAD085-E8A6-8845-BD4E-CB4CCA059FC4}" type="datetimeFigureOut">
               <a:rPr lang="en-US" smtClean="0"/>
-              <a:t>09/03/2026</a:t>
+              <a:t>09/04/2026</a:t>
             </a:fld>
             <a:endParaRPr lang="en-US"/>
           </a:p>
@@ -1990,7 +1990,7 @@
           <a:p>
             <a:fld id="{5BCAD085-E8A6-8845-BD4E-CB4CCA059FC4}" type="datetimeFigureOut">
               <a:rPr lang="en-US" smtClean="0"/>
-              <a:t>09/03/2026</a:t>
+              <a:t>09/04/2026</a:t>
             </a:fld>
             <a:endParaRPr lang="en-US"/>
           </a:p>
@@ -2265,7 +2265,7 @@
           <a:p>
             <a:fld id="{5BCAD085-E8A6-8845-BD4E-CB4CCA059FC4}" type="datetimeFigureOut">
               <a:rPr lang="en-US" smtClean="0"/>
-              <a:t>09/03/2026</a:t>
+              <a:t>09/04/2026</a:t>
             </a:fld>
             <a:endParaRPr lang="en-US"/>
           </a:p>
@@ -2517,7 +2517,7 @@
           <a:p>
             <a:fld id="{5BCAD085-E8A6-8845-BD4E-CB4CCA059FC4}" type="datetimeFigureOut">
               <a:rPr lang="en-US" smtClean="0"/>
-              <a:t>09/03/2026</a:t>
+              <a:t>09/04/2026</a:t>
             </a:fld>
             <a:endParaRPr lang="en-US"/>
           </a:p>
@@ -2728,7 +2728,7 @@
           <a:p>
             <a:fld id="{5BCAD085-E8A6-8845-BD4E-CB4CCA059FC4}" type="datetimeFigureOut">
               <a:rPr lang="en-US" smtClean="0"/>
-              <a:t>09/03/2026</a:t>
+              <a:t>09/04/2026</a:t>
             </a:fld>
             <a:endParaRPr lang="en-US"/>
           </a:p>
@@ -16651,7 +16651,7 @@
         </p:nvSpPr>
         <p:spPr>
           <a:xfrm>
-            <a:off x="6524625" y="3793331"/>
+            <a:off x="6524625" y="4025502"/>
             <a:ext cx="4857750" cy="621506"/>
           </a:xfrm>
           <a:prstGeom prst="rect">
@@ -22170,8 +22170,8 @@
         </p:blipFill>
         <p:spPr>
           <a:xfrm>
-            <a:off x="5096502" y="2867620"/>
-            <a:ext cx="628650" cy="189904"/>
+            <a:off x="5096501" y="2867619"/>
+            <a:ext cx="667775" cy="201723"/>
           </a:xfrm>
           <a:prstGeom prst="rect">
             <a:avLst/>
@@ -22266,8 +22266,8 @@
         </p:blipFill>
         <p:spPr>
           <a:xfrm>
-            <a:off x="5076080" y="3231863"/>
-            <a:ext cx="971550" cy="206066"/>
+            <a:off x="5037782" y="3223740"/>
+            <a:ext cx="1009848" cy="214189"/>
           </a:xfrm>
           <a:prstGeom prst="rect">
             <a:avLst/>
@@ -22458,8 +22458,8 @@
         </p:blipFill>
         <p:spPr>
           <a:xfrm>
-            <a:off x="5107372" y="3999309"/>
-            <a:ext cx="940258" cy="199429"/>
+            <a:off x="5040479" y="3985121"/>
+            <a:ext cx="1007151" cy="213617"/>
           </a:xfrm>
           <a:prstGeom prst="rect">
             <a:avLst/>
@@ -22506,8 +22506,8 @@
         </p:blipFill>
         <p:spPr>
           <a:xfrm>
-            <a:off x="8304725" y="4008834"/>
-            <a:ext cx="971550" cy="189904"/>
+            <a:off x="8298576" y="3984723"/>
+            <a:ext cx="1128893" cy="220659"/>
           </a:xfrm>
           <a:prstGeom prst="rect">
             <a:avLst/>
@@ -22554,8 +22554,8 @@
         </p:blipFill>
         <p:spPr>
           <a:xfrm>
-            <a:off x="5076080" y="4365856"/>
-            <a:ext cx="1096357" cy="214299"/>
+            <a:off x="5037782" y="4358370"/>
+            <a:ext cx="1134655" cy="221785"/>
           </a:xfrm>
           <a:prstGeom prst="rect">
             <a:avLst/>
@@ -22602,7 +22602,7 @@
         </p:blipFill>
         <p:spPr>
           <a:xfrm>
-            <a:off x="8341670" y="4389238"/>
+            <a:off x="8298576" y="4389238"/>
             <a:ext cx="682374" cy="206133"/>
           </a:xfrm>
           <a:prstGeom prst="rect">

</xml_diff>